<commit_message>
Add word-for-word speaker script in the PowerPoint notes and as a Word file
Notes on every slide are now the exact words to say, with [actions] marked
separately and timings that add up to about 14 minutes. The Word file has
the same script with slide thumbnails, a time plan, pronunciation help and
short answers to likely questions. Replaces the Markdown script.

Co-Authored-By: Claude Sonnet 5.5 <noreply@anthropic.com>
Claude-Session: https://claude.ai/code/session_01XVn4nhm1FHbhKAQZgBzJgg
</commit_message>
<xml_diff>
--- a/gothic-architecture/Gothic_Architecture.pptx
+++ b/gothic-architecture/Gothic_Architecture.pptx
@@ -120,33 +120,33 @@
   <p:extLst>
     <p:ext uri="{521415D9-36F7-43E2-AB2F-B90AF26B5E84}">
       <p14:sectionLst xmlns:p14="http://schemas.microsoft.com/office/powerpoint/2010/main">
-        <p14:section name="Opening" id="{bb64cdfd-935a-393f-3bf7-12cdb372fdde}">
+        <p14:section name="Opening" id="{f9699711-cb55-e335-0ee0-24905a40c2ee}">
           <p14:sldIdLst>
             <p14:sldId id="256"/>
             <p14:sldId id="257"/>
           </p14:sldIdLst>
         </p14:section>
-        <p14:section name="Origins" id="{1f6c1065-0f95-6366-548a-5e771e55452d}">
+        <p14:section name="Origins" id="{1f209f22-0d63-6ce3-323a-01108912b48f}">
           <p14:sldIdLst>
             <p14:sldId id="258"/>
             <p14:sldId id="259"/>
           </p14:sldIdLst>
         </p14:section>
-        <p14:section name="Structure" id="{0562fe5b-1663-b3a2-f0c6-f6136567ba11}">
+        <p14:section name="Structure" id="{71420098-f383-aa50-a165-60276cd5b03f}">
           <p14:sldIdLst>
             <p14:sldId id="260"/>
             <p14:sldId id="261"/>
             <p14:sldId id="262"/>
           </p14:sldIdLst>
         </p14:section>
-        <p14:section name="Space and making" id="{dc78b923-9281-386e-3df8-1dee68df6e98}">
+        <p14:section name="Space and making" id="{f6fa444a-0841-5745-3304-75e20385af82}">
           <p14:sldIdLst>
             <p14:sldId id="263"/>
             <p14:sldId id="264"/>
             <p14:sldId id="265"/>
           </p14:sldIdLst>
         </p14:section>
-        <p14:section name="Legacy" id="{ef5fb9dd-ecbb-1af5-e65a-f49a61ff2169}">
+        <p14:section name="Legacy" id="{45c995cf-5ece-b5b1-5152-fcad7ab324fe}">
           <p14:sldIdLst>
             <p14:sldId id="266"/>
             <p14:sldId id="267"/>
@@ -890,10 +890,13 @@
           <a:p>
             <a:r>
               <a:rPr lang="en-US" dirty="0"/>
-              <a:t>[SLIDE 1 OF 13 · aim for 0:40]
-Good morning everyone, my name is [your name]. Today I will take you on a 15-minute journey through one of the most powerful ideas in architecture: Gothic architecture.
-[Point to the picture: Cologne Cathedral at dusk.] Imagine you are a farmer in the year 1200. You live in a small, dark house with one tiny window. One Sunday you walk into a cathedral. The walls seem to disappear. Coloured light falls on the floor. The ceiling is thirty metres above your head. For you, it feels like walking into heaven. That is exactly what the builders wanted.
-I will answer four questions: where does Gothic come from, why was it built, how does it stand up, and what did it leave us?</a:t>
+              <a:t>SLIDE 1 OF 13  ·  GOTHIC ARCHITECTURE (TITLE)
+About 0:45 on this slide  ·  clock 0:00 to 0:45
+Say the text below word for word. Words in [brackets] are actions: do them, do not read them out.
+[Wait for the first slide to appear. Smile and look at the audience.]
+Good morning everyone. My name is [your name], and today I will talk about Gothic architecture.
+[Point to the picture.] This is Cologne Cathedral, in Germany. Imagine you are a farmer in the year 1200. You live in a small, dark house. One Sunday, you walk into a cathedral like this one. The walls seem to disappear. Coloured light falls on the floor. The ceiling is thirty metres above your head. It feels like walking into heaven. That is exactly what the builders wanted.
+I will answer four questions. Where does Gothic come from? Why was it built? How does it stand up? And what did it leave us?</a:t>
             </a:r>
             <a:endParaRPr lang="en-US" dirty="0"/>
           </a:p>
@@ -981,14 +984,16 @@
           <a:p>
             <a:r>
               <a:rPr lang="en-US" dirty="0"/>
-              <a:t>[SLIDE 10 OF 13 · aim for 1:10]
-How do you build this with no computer, no engine and no calculation of forces? Five steps.
-One, money: the bishop, the king, the guilds and the pilgrims. Often the money ran out and work stopped for years.
-Two, design. There was no architect with a diploma. There was the master mason: designer, engineer and site manager in one. He used geometry: compass, straightedge, circles, squares, triangles. The same tools we use in our drawing class! He drew full-size templates, even on plaster floors. Some of these tracing floors survive in England, at York and Wells.
-Three, carving. Masons cut each stone on the ground and marked it with a personal sign, so they could be paid.
-Four, lifting. Treadwheel cranes, like giant hamster wheels with workers walking inside. Arches and vaults were built on wooden frames, called centering, removed once the keystone was in place.
-Five, time. Notre-Dame took about 180 years. Cologne, the cathedral you see on the right, took 632. A mason who started a cathedral knew he would never see it finished. Gothic is architecture as a collective act, across generations.
-NEXT: And sometimes the ambition went too far.</a:t>
+              <a:t>SLIDE 10 OF 13  ·  BUILT BY GENERATIONS, NOT BY ONE GENIUS
+About 1:15 on this slide  ·  clock 10:00 to 11:15
+Say the text below word for word. Words in [brackets] are actions: do them, do not read them out.
+How do you build this with no computer and no engine? Five steps.
+One, money. The bishop, the king, the guilds and the pilgrims paid. Often the money ran out, and work stopped for years.
+Two, design. There was no architect with a diploma. There was the master mason: designer, engineer and site manager in one. He used geometry: compass, straightedge, circles, squares and triangles. The same tools we use in our drawing class! He even drew full-size templates on plaster floors.
+Three, carving. The masons cut each stone on the ground and marked it with a personal sign, so they could be paid.
+Four, lifting. Treadwheel cranes, like giant hamster wheels with workers walking inside. Arches were built on wooden frames, called centering, removed when the keystone was in place.
+Five, time. Notre-Dame took about 180 years. Cologne, on the right, took 632. A mason who started a cathedral knew that he would never see it finished. Gothic is architecture across generations.
+But sometimes, the ambition went too far.</a:t>
             </a:r>
             <a:endParaRPr lang="en-US" dirty="0"/>
           </a:p>
@@ -1076,12 +1081,14 @@
           <a:p>
             <a:r>
               <a:rPr lang="en-US" dirty="0"/>
-              <a:t>[SLIDE 11 OF 13 · aim for 1:05]
-Here is the race to the sky. The chart shows the height of the main vault above the floor. Notre-Dame: 33 metres. Chartres: 37. Reims: 38. Amiens: 42. Beauvais: 48. In about 60 years, the height grew by almost half. Bishops wanted to beat each other.
-But Beauvais went too far. In 1284, only twelve years after the choir was finished, part of the vault collapsed. The builders added extra piers, but the cathedral was never completed. Beauvais still has the tallest Gothic choir ever built, and one of the most famous failures.
-Why? There was no mathematics of structures yet. Master masons learned by trial and error, and every collapse was a lesson. This is how structural engineering was born: building, failing, improving.
+              <a:t>SLIDE 11 OF 13  ·  THE RACE TO THE SKY
+About 1:00 on this slide  ·  clock 11:15 to 12:15
+Say the text below word for word. Words in [brackets] are actions: do them, do not read them out.
+Here is the race to the sky. [Point to the chart.] The height of the main vault: Notre-Dame, 33 metres. Chartres, 37. Reims, 38. Amiens, 42. And Beauvais, 48 metres. In about 60 years, the height grew by almost half. The bishops wanted to beat each other.
+But Beauvais went too far. In 1284, only twelve years after the choir was finished, part of the vault collapsed. The builders added extra piers, but the cathedral was never completed.
+Why did this happen? There was no mathematics of structures yet. The masons learned by trial and error, and every collapse was a lesson. This is how structural engineering was born: building, failing, and improving.
 As students, I find this inspiring: every bold idea has a risk.
-NEXT: What happened to Gothic after the Middle Ages?</a:t>
+So, what happened to Gothic after the Middle Ages?</a:t>
             </a:r>
             <a:endParaRPr lang="en-US" dirty="0"/>
           </a:p>
@@ -1169,12 +1176,14 @@
           <a:p>
             <a:r>
               <a:rPr lang="en-US" dirty="0"/>
-              <a:t>[SLIDE 12 OF 13 · aim for 1:10]
-The story has three acts: spread, decline and rebirth. [Point to the three pictures: Cologne, a Renaissance dome, and the clock tower of the Houses of Parliament.]
-Spread. From France, Gothic travels across Europe, and each country adds its own accent. England: Salisbury and Westminster Abbey. Germany: Cologne, with its huge twin towers. Italy: the Duomo of Milan, in white marble. Spain: Seville, the largest Gothic cathedral in the world.
-Decline. In the 1400s the Renaissance looked back to ancient Rome: columns, domes, symmetry. For writers like Vasari, medieval buildings were barbaric. They called them "Gothic", after the Goths who destroyed Rome. So the name we use today started as an insult!
-Rebirth. In the 1800s Europe fell in love with the Middle Ages again. The Houses of Parliament in London, by Barry and Pugin, are Gothic Revival. Viollet-le-Duc (say "vee-oh-LAY luh DUKE") restored Notre-Dame. Gaudí began the Sagrada Família in 1882. And in April 2019 a terrible fire hit Notre-Dame. After five years of work, it reopened in December 2024.
-NEXT: So what do we keep from Gothic?</a:t>
+              <a:t>SLIDE 12 OF 13  ·  SPREAD, DECLINE AND REBIRTH
+About 1:05 on this slide  ·  clock 12:15 to 13:20
+Say the text below word for word. Words in [brackets] are actions: do them, do not read them out.
+The story has three acts. [Point to the three pictures: Cologne, a Renaissance dome, and the clock tower of the Houses of Parliament.]
+Act one, spread. From France, Gothic travels across Europe, and each country adds its own accent: Salisbury and Westminster in England, Cologne in Germany, the Duomo in Milan, and Seville in Spain, the largest Gothic cathedral in the world.
+Act two, decline. In the 1400s, the Renaissance looked back to ancient Rome: columns, domes, symmetry. For writers like Vasari, medieval buildings were barbaric. They called them "Gothic", after the Goths who destroyed Rome. So the name we use today started as an insult!
+Act three, rebirth. In the 1800s, Europe fell in love with the Middle Ages again. The Houses of Parliament in London are Gothic Revival. Viollet-le-Duc [say "vee-oh-LAY luh DUKE"] restored Notre-Dame. Gaudí began the Sagrada Família in 1882. And in April 2019, a terrible fire hit Notre-Dame. After five years of work, it reopened in December 2024.
+So, what do we keep from Gothic?</a:t>
             </a:r>
             <a:endParaRPr lang="en-US" dirty="0"/>
           </a:p>
@@ -1262,18 +1271,28 @@
           <a:p>
             <a:r>
               <a:rPr lang="en-US" dirty="0"/>
-              <a:t>[SLIDE 13 OF 13 · aim for 0:50]
-Slow and confident.
+              <a:t>SLIDE 13 OF 13  ·  WHAT GOTHIC TEACHES AN ARCHITECT
+About 0:40 on this slide  ·  clock 13:20 to 14:00
+Say the text below word for word. Words in [brackets] are actions: do them, do not read them out.
+[Speak slowly and confidently.]
 In one sentence: the Gothic builders took the heaviest material, stone, and turned it into light.
 Three lessons for future architects.
 One: structure can be beauty. In Gothic, the skeleton is the design. A frame with a glass skin is the ancestor of the modern skyscraper.
 Two: light is a material. Think about how you will use light in your own projects.
 Three: great architecture can take generations. It needs hundreds of hands and one shared dream.
 Thank you very much for your attention. I am happy to answer your questions.
-POSSIBLE QUESTIONS, QUICK ANSWERS (not to be read out)
-- Gothic versus Romanesque? Romanesque: round arch, thick walls, small windows. Gothic: pointed arch, ribbed vault, flying buttress, big windows.
-- Why gargoyles? They are water spouts that throw rainwater away from the walls. They also had a symbolic role: protecting the church from evil.
-- Why was the Notre-Dame fire so serious? The roof frame, mostly 13th-century oak, burned and the spire collapsed. The stone vaults stopped most of the fire from reaching the inside.</a:t>
+----------
+IF SOMEONE ASKS (short answers, not to be read out)
+Q: What is the difference between Gothic and Romanesque?
+A: Romanesque has round arches, thick walls and small windows. Gothic has pointed arches, ribbed vaults, flying buttresses and big windows.
+Q: Why are there gargoyles?
+A: They are water spouts. They throw the rainwater away from the walls. They also had a symbolic role: protecting the church from evil.
+Q: Why was the Notre-Dame fire so serious?
+A: The roof frame, mostly 13th-century oak, burned and the spire collapsed. The stone vaults stopped most of the fire from reaching the inside.
+Q: Why did cathedrals take so long to build?
+A: Money came slowly from donations, and building stopped in winter, during wars and after the Black Death. Many were finished by the grandchildren of the first builders.
+Q: Is the pointed arch really stronger than the round arch?
+A: It pushes less sideways for the same span, so thinner supports can carry it. The round arch is not weak, but it needs more mass to resist its thrust.</a:t>
             </a:r>
             <a:endParaRPr lang="en-US" dirty="0"/>
           </a:p>
@@ -1362,7 +1381,7 @@
             <a:r>
               <a:rPr lang="en-US" dirty="0"/>
               <a:t>Do not present this slide. Keep it for questions, or for your teacher.
-All diagrams in this presentation were drawn specially for it. If your teacher asks for exact sources, double-check the construction dates and the vault heights of each cathedral in the books listed here.</a:t>
+All illustrations in this presentation were drawn for it. If your teacher asks for exact sources, check the construction dates and the vault heights of each cathedral in the books listed here.</a:t>
             </a:r>
             <a:endParaRPr lang="en-US" dirty="0"/>
           </a:p>
@@ -1450,14 +1469,15 @@
           <a:p>
             <a:r>
               <a:rPr lang="en-US" dirty="0"/>
-              <a:t>[SLIDE 2 OF 13 · aim for 0:45]
-Before the details, four numbers. [Point to each card.]
-1140: the year Abbot Suger started rebuilding the church of Saint-Denis, near Paris. Most historians see it as the birth of Gothic.
-About 400 years: how long Gothic dominated building in Europe. It is not a trend, it is a whole civilisation.
+              <a:t>SLIDE 2 OF 13  ·  WHY DOES IT STILL GIVE US CHILLS?
+About 0:45 on this slide  ·  clock 0:45 to 1:30
+Say the text below word for word. Words in [brackets] are actions: do them, do not read them out.
+Let me start with four numbers. [Point to each number as you say it.]
+1140: the year when Abbot Suger started rebuilding the church of Saint-Denis, near Paris. Most historians see it as the birth of Gothic.
+About 400 years: how long Gothic dominated building in Europe. It was not a fashion. It was a whole civilisation.
 48 metres: the vault of Beauvais Cathedral. That is a 16-storey building, in the 13th century, with no steel and no concrete.
 632 years: Cologne Cathedral was started in 1248 and finished in 1880.
-At the bottom you can see our road map: faith and origins, structure, space and making, and legacy.
-NEXT: So, when did all this happen?</a:t>
+At the bottom, you can see our road map. So, let's begin. When did all this happen?</a:t>
             </a:r>
             <a:endParaRPr lang="en-US" dirty="0"/>
           </a:p>
@@ -1545,14 +1565,16 @@
           <a:p>
             <a:r>
               <a:rPr lang="en-US" dirty="0"/>
-              <a:t>[SLIDE 3 OF 13 · aim for 1:05]
-Gothic was not invented in one day. Historians divide it into four chapters. [Move your hand from left to right.]
-Early Gothic, 1140 to 1200. It starts at Saint-Denis, then Notre-Dame de Paris, begun in 1163.
-High Gothic, 1200 to 1240, the golden age: Chartres (say "SHAR-truh"), Reims and Amiens. Everything becomes taller and lighter.
-Rayonnant, 1240 to 1350. The word means "radiating", like rays of light. Walls almost disappear and become glass held by thin stone patterns called tracery. The masterpiece is the Sainte-Chapelle in Paris.
-Late Gothic, 1350 to about 1520. Decoration explodes. In France it is called Flamboyant, because the tracery looks like flames. In England, Perpendicular, with fan-shaped vaults. And in 1347 the Black Death kills maybe a third of Europe's people, so many cathedrals slow down or stop.
-A small fact: nobody at the time said "Gothic". We come back to this word at the end.
-NEXT: But why spend so much money on these buildings?</a:t>
+              <a:t>SLIDE 3 OF 13  ·  FOUR CENTURIES IN FOUR CHAPTERS
+About 1:15 on this slide  ·  clock 1:30 to 2:45
+Say the text below word for word. Words in [brackets] are actions: do them, do not read them out.
+Gothic was not invented in one day. Historians divide it into four chapters. [Move your hand from left to right along the slide.]
+Chapter one: Early Gothic, 1140 to 1200. It starts at Saint-Denis, and then Notre-Dame de Paris, in 1163. See the window: simple, tall and narrow.
+Chapter two: High Gothic, 1200 to 1240. The golden age: Chartres [say "SHAR-truh"], Reims and Amiens. Everything becomes taller and lighter, with a round rose window above.
+Chapter three: Rayonnant, 1240 to 1350. It means "radiating", like rays of light. The walls almost disappear and become glass, held by thin stone patterns called tracery. The masterpiece is the Sainte-Chapelle in Paris.
+Chapter four: Late Gothic, 1350 to about 1520. Decoration explodes. In France it is called Flamboyant, because the stone looks like flames. And in 1347, the Black Death kills maybe a third of Europe's people, so many cathedrals slow down or stop.
+One small fact: nobody at the time said the word "Gothic". I will come back to this at the end.
+But first: why did people spend so much money on these buildings?</a:t>
             </a:r>
             <a:endParaRPr lang="en-US" dirty="0"/>
           </a:p>
@@ -1640,13 +1662,15 @@
           <a:p>
             <a:r>
               <a:rPr lang="en-US" dirty="0"/>
-              <a:t>[SLIDE 4 OF 13 · aim for 1:15]
-To understand Gothic, we must understand medieval faith. In the 12th century, Christianity organised everything. Three ideas.
-First, light is divine. [Point to the quote.] Abbot Suger (say "soo-ZHAY"), abbot of Saint-Denis and adviser to the French kings, read a philosopher who taught that God is pure light. So he rebuilt his church to be flooded with light. He wrote: "The dull mind rises to truth through that which is material." In other words, beautiful matter, like stone, gold and coloured glass, can lift the soul towards God.
-Second, Mary and the pilgrims. Notre-Dame means "Our Lady", the Virgin Mary. Relics, like the cloth said to be Mary's tunic at Chartres, attracted thousands of pilgrims. They needed big space, and their donations helped pay for it.
-Third, power and pride. Bishops, kings and rich cities competed. A taller cathedral meant a more important city. It was also the town's meeting place, market and school.
-The Bible describes heaven as the Heavenly Jerusalem, a city of light and jewels. A Gothic cathedral tries to build it on earth.
-NEXT: Faith explains why. What made it possible?</a:t>
+              <a:t>SLIDE 4 OF 13  ·  A HEAVEN MADE OF STONE
+About 1:20 on this slide  ·  clock 2:45 to 4:05
+Say the text below word for word. Words in [brackets] are actions: do them, do not read them out.
+To understand Gothic, we must understand medieval faith. I will give you three ideas.
+First, light is divine. [Point to the quote.] Abbot Suger [say "soo-ZHAY"] was an adviser to the kings of France. He read a philosopher who taught that God is pure light. So he rebuilt his church to be full of light. He wrote: "The dull mind rises to truth through that which is material." In simple words: beautiful things, like stone, gold and coloured glass, can lift the soul towards God.
+Second, Mary and the pilgrims. Notre-Dame means "Our Lady", the Virgin Mary. Relics attracted thousands of pilgrims. They needed a lot of space, and their donations helped to pay for the building.
+Third, power and pride. Bishops, kings and rich cities competed. A taller cathedral meant a more important city. It was also the meeting place, the market and the school of the town.
+The Bible describes heaven as the Heavenly Jerusalem, a city of light and jewels. A Gothic cathedral tries to build this picture on earth.
+So faith explains why. But what made it possible?</a:t>
             </a:r>
             <a:endParaRPr lang="en-US" dirty="0"/>
           </a:p>
@@ -1734,12 +1758,14 @@
           <a:p>
             <a:r>
               <a:rPr lang="en-US" dirty="0"/>
-              <a:t>[SLIDE 5 OF 13 · aim for 0:50]
-Go quickly, row by row.
-Before Gothic, Europe built in the Romanesque style. Look at the left: round arches, thick walls like a fortress, small windows, because every hole weakens a thick wall. The result is dark, solid, protective.
-On the right, Gothic: pointed arches, light vaults, thin walls, enormous windows. The result is tall, bright and, for people at the time, heavenly.
-The key point: Gothic did not use a new material. It is still stone. What changed is the logic. A Romanesque church is a heavy mass; a Gothic church is a skeleton. It is the difference between a cave and a tent with poles.
-NEXT: This skeleton is made of three inventions.</a:t>
+              <a:t>SLIDE 5 OF 13  ·  FROM FORTRESS-CHURCH TO LANTERN
+About 0:50 on this slide  ·  clock 4:05 to 4:55
+Say the text below word for word. Words in [brackets] are actions: do them, do not read them out.
+[Go quickly, row by row.]
+Before Gothic, Europe built in the Romanesque style. On the left: round arches, thick walls like a fortress, and small windows, because every hole makes a thick wall weaker. The result is dark, solid and protective.
+On the right, Gothic: pointed arches, light vaults, thin walls and enormous windows. The result is tall, bright and, for people at that time, heavenly.
+The key point: Gothic did not use a new material. It is still stone. What changed is the logic. A Romanesque church is a heavy mass. A Gothic church is a skeleton. It is the difference between a cave and a tent with poles.
+This skeleton is made of three inventions.</a:t>
             </a:r>
             <a:endParaRPr lang="en-US" dirty="0"/>
           </a:p>
@@ -1827,13 +1853,14 @@
           <a:p>
             <a:r>
               <a:rPr lang="en-US" dirty="0"/>
-              <a:t>[SLIDE 6 OF 13 · aim for 1:20]
-Three inventions. [Point to each card.]
-One: the pointed arch. A round arch pushes strongly outwards. The pointed arch has steeper sides, so more weight goes straight down and less pushes sideways. See the red arrows: they are much shorter. And you can make it as tall as you want for the same width, which is perfect for covering rectangular spaces.
-Two: the ribbed vault. This is a plan from above. The ribs, in gold, cross diagonally. Masons built the ribs first, then filled between them with thin, light panels. The ribs collect the weight and send it down to the corners, the piers. So the wall no longer carries the roof. Only the points do.
+              <a:t>SLIDE 6 OF 13  ·  THREE IDEAS THAT CHANGED EVERYTHING
+About 1:15 on this slide  ·  clock 4:55 to 6:10
+Say the text below word for word. Words in [brackets] are actions: do them, do not read them out.
+Here are the three inventions. [Point to each card as you speak.]
+One: the pointed arch. A round arch pushes strongly outwards. Look at the red arrows. The pointed arch has steeper sides, so more weight goes straight down, and less pushes sideways. And you can make it as tall as you want for the same width.
+Two: the ribbed vault. This is a plan seen from above. The ribs, in gold, cross diagonally. The masons built the ribs first, then filled between them with thin, light panels. The ribs send the weight down to the corners, to the piers. So the wall does not carry the roof any more. Only the points do.
 Three: the flying buttress. The vault still pushes outwards at the top of the wall. The flying buttress is a half-arch, outside the church, that catches this push and carries it over the side aisle to a heavy pier.
-Together: a stone skeleton with its bones on the outside. Now the walls are free to become windows.
-NEXT: Let's see them working together.</a:t>
+Together, they make a stone skeleton with its bones on the outside. Now the walls are free to become windows. Let me show you all three working together.</a:t>
             </a:r>
             <a:endParaRPr lang="en-US" dirty="0"/>
           </a:p>
@@ -1921,17 +1948,18 @@
           <a:p>
             <a:r>
               <a:rPr lang="en-US" dirty="0"/>
-              <a:t>[SLIDE 7 OF 13 · aim for 1:20]
-This is the technical heart of the talk, so slow down.
-This is a cross-section through a nave, like cutting the cathedral with a knife. Let's follow the force, like water running downhill.
-1: the stone vault is heavy. It pushes down and outwards at the top of the wall.
-2: at exactly that height, the flying buttress catches the push and sends it diagonally down and outwards, over the side aisle.
-3: the pinnacle, the little spire on the outer pier. It looks decorative, but its weight presses down on the pier and keeps the line of force inside it, so the pier does not tip over.
-4: the pier brings everything to the ground.
-So what is left for the wall to do? Almost nothing. That is why the upper wall can be filled with glass.
-Notice the three levels inside: the arcade at the bottom, the triforium, a narrow passage, in the middle, and at the top the clerestory (say "CLEAR-story"), the high windows that bring in the light.
-An image to remember: a cathedral is an exoskeleton, like a crab.
-NEXT: And what does this structure give us? Light.</a:t>
+              <a:t>SLIDE 7 OF 13  ·  FOLLOW THE FORCE
+About 1:20 on this slide  ·  clock 6:10 to 7:30
+Say the text below word for word. Words in [brackets] are actions: do them, do not read them out.
+This is the technical heart of my talk, so I will go slowly. [Point to the drawing.]
+This is a cross-section through the nave, like cutting the cathedral with a knife. Let's follow the force, like water running downhill.
+One: the stone vault is heavy. It pushes down and outwards, at the top of the wall.
+Two: at exactly that height, the flying buttress catches the push and sends it diagonally down, over the side aisle.
+Three: the pinnacle, the small spire on the outer pier. It looks like decoration, but its weight presses down on the pier and keeps the force inside it, so the pier does not tip over.
+Four: the pier brings everything to the ground.
+So what is left for the wall to do? Almost nothing. That is why it can be filled with glass.
+Look at the three levels inside: the arcade at the bottom, the triforium, a narrow passage, in the middle, and at the top the clerestory [say "CLEAR-story"], the high windows that bring in the light.
+A cathedral is an exoskeleton, like a crab. And what does this skeleton give us? Light.</a:t>
             </a:r>
             <a:endParaRPr lang="en-US" dirty="0"/>
           </a:p>
@@ -2019,14 +2047,16 @@
           <a:p>
             <a:r>
               <a:rPr lang="en-US" dirty="0"/>
-              <a:t>[SLIDE 8 OF 13 · aim for 1:10]
+              <a:t>SLIDE 8 OF 13  ·  WALLS MADE OF LIGHT
+About 1:15 on this slide  ·  clock 7:30 to 8:45
+Say the text below word for word. Words in [brackets] are actions: do them, do not read them out.
 Remember Suger: light is divine. All this structure exists to give us this: walls made of light.
-How is stained glass made? Glassmakers added metal oxides to melted glass: cobalt gives blue, copper gives red. The pieces were cut, joined with strips of lead, and held in iron frames and stone tracery. When the sun shines, coloured light moves across the floor. The building changes with the hour.
-The windows were also books. Most people could not read, so the glass told Bible stories and the lives of saints in pictures.
-The best example is the Sainte-Chapelle in Paris, built between 1241 and 1248 for King Louis IX, to hold what he believed was the Crown of Thorns. Fifteen windows, about fifteen metres tall, 1,113 scenes. Inside, it feels like a jewellery box.
-The round window here is a rose window: a circle of stone patterns holding glass, on the front or the ends of the transept.
-If you remember one thing: in Gothic, light is a building material.
-NEXT: Now let's walk inside and learn to read a cathedral.</a:t>
+How is stained glass made? The glassmakers added metal oxides to melted glass. Cobalt gives blue, and copper gives red. The pieces were joined with strips of lead and held in stone patterns. When the sun shines, coloured light moves across the floor. The building changes with the hour.
+The windows were also books. Most people could not read, so the glass told Bible stories in pictures.
+The best example is the Sainte-Chapelle in Paris, built between 1241 and 1248 for King Louis the Ninth, to hold what he believed was the Crown of Thorns. [Point to the numbers.] Fifteen windows, fifteen metres tall, and 1,113 scenes. Inside, it feels like a jewellery box.
+The round window is a rose window: a circle of stone patterns holding glass.
+If you remember only one thing from my talk: in Gothic, light is a building material.
+Now let's walk inside and learn how to read a cathedral.</a:t>
             </a:r>
             <a:endParaRPr lang="en-US" dirty="0"/>
           </a:p>
@@ -2114,12 +2144,14 @@
           <a:p>
             <a:r>
               <a:rPr lang="en-US" dirty="0"/>
-              <a:t>[SLIDE 9 OF 13 · aim for 1:10]
-Use your hand to "walk" on the plan.
-Start with the plan, on the left. It is a Latin cross: a long arm and a short arm. It symbolises the cross of Christ. The altar is at the east end, towards the sunrise and Jerusalem.
-Walk with me from the main door in the west: number 5, the west front. You enter the nave, number 1: the long hall for the people, with an aisle on each side. Then the transept, number 2: the arms of the cross. Then the choir, number 3: the place for the clergy and the altar. And around the end, number 4: the ambulatory and the radiating chapels. The ambulatory lets pilgrims circulate and see the relics without disturbing the service.
-Now the facade, on the right. A: three deep portals covered with sculpture. Over the central door you often find the Last Judgement. People who could not read learnt the Christian story from stone. B: the rose window. C: the two towers, like Notre-Dame.
-NEXT: Good. But who built all this, and how?</a:t>
+              <a:t>SLIDE 9 OF 13  ·  READING A CATHEDRAL
+About 1:15 on this slide  ·  clock 8:45 to 10:00
+Say the text below word for word. Words in [brackets] are actions: do them, do not read them out.
+[Use your hand to "walk" on the plan.]
+On the left, the plan. It is a Latin cross: a long arm and a short arm. It symbolises the cross of Christ. The altar is at the east end, towards the sunrise and Jerusalem.
+Walk with me from the main door, in the west. Number five, the west front. You enter the nave, number one: the long hall for the people, with an aisle on each side. Then the transept, number two: the arms of the cross. Then the choir, number three: the place for the clergy and the altar. And around the end, number four: the ambulatory and the radiating chapels. The ambulatory lets pilgrims walk around and see the relics without disturbing the service.
+Now the facade, on the right. A: three deep portals, covered with sculpture. Above the central door you often find the Last Judgement. People who could not read learned the Christian story from the stone. B: the rose window. C: the two towers, like Notre-Dame.
+But who built all this, and how?</a:t>
             </a:r>
             <a:endParaRPr lang="en-US" dirty="0"/>
           </a:p>

</xml_diff>